<commit_message>
Review fixes: clearer rules, 4th example, layout examples, friendlier errors (v3)
</commit_message>
<xml_diff>
--- a/Incident_Classification_slides.pptx
+++ b/Incident_Classification_slides.pptx
@@ -9898,7 +9898,7 @@
         <p:spPr>
           <a:xfrm>
             <a:off x="841248" y="2606040"/>
-            <a:ext cx="2015337" cy="2788920"/>
+            <a:ext cx="2015337" cy="3154680"/>
           </a:xfrm>
           <a:prstGeom prst="roundRect">
             <a:avLst>
@@ -9943,8 +9943,8 @@
         </p:nvSpPr>
         <p:spPr>
           <a:xfrm>
-            <a:off x="914400" y="2670048"/>
-            <a:ext cx="1869033" cy="2651760"/>
+            <a:off x="896112" y="2651760"/>
+            <a:ext cx="1905609" cy="3108960"/>
           </a:xfrm>
           <a:prstGeom prst="rect">
             <a:avLst/>
@@ -9957,7 +9957,7 @@
           <a:p>
             <a:pPr algn="l"/>
             <a:r>
-              <a:rPr sz="1400" b="0">
+              <a:rPr sz="1050" b="0">
                 <a:solidFill>
                   <a:srgbClr val="262626"/>
                 </a:solidFill>
@@ -10036,7 +10036,7 @@
         <p:spPr>
           <a:xfrm>
             <a:off x="2966313" y="2606040"/>
-            <a:ext cx="2015337" cy="2788920"/>
+            <a:ext cx="2015337" cy="3154680"/>
           </a:xfrm>
           <a:prstGeom prst="roundRect">
             <a:avLst>
@@ -10081,8 +10081,8 @@
         </p:nvSpPr>
         <p:spPr>
           <a:xfrm>
-            <a:off x="3039465" y="2670048"/>
-            <a:ext cx="1869033" cy="2651760"/>
+            <a:off x="3021177" y="2651760"/>
+            <a:ext cx="1905609" cy="3108960"/>
           </a:xfrm>
           <a:prstGeom prst="rect">
             <a:avLst/>
@@ -10095,7 +10095,7 @@
           <a:p>
             <a:pPr algn="l"/>
             <a:r>
-              <a:rPr sz="1400" b="0">
+              <a:rPr sz="1050" b="0">
                 <a:solidFill>
                   <a:srgbClr val="262626"/>
                 </a:solidFill>
@@ -10174,7 +10174,7 @@
         <p:spPr>
           <a:xfrm>
             <a:off x="5091379" y="2606040"/>
-            <a:ext cx="2015337" cy="2788920"/>
+            <a:ext cx="2015337" cy="3154680"/>
           </a:xfrm>
           <a:prstGeom prst="roundRect">
             <a:avLst>
@@ -10219,8 +10219,8 @@
         </p:nvSpPr>
         <p:spPr>
           <a:xfrm>
-            <a:off x="5164531" y="2670048"/>
-            <a:ext cx="1869033" cy="2651760"/>
+            <a:off x="5146243" y="2651760"/>
+            <a:ext cx="1905609" cy="3108960"/>
           </a:xfrm>
           <a:prstGeom prst="rect">
             <a:avLst/>
@@ -10233,7 +10233,7 @@
           <a:p>
             <a:pPr algn="l"/>
             <a:r>
-              <a:rPr sz="1400" b="0">
+              <a:rPr sz="1050" b="0">
                 <a:solidFill>
                   <a:srgbClr val="262626"/>
                 </a:solidFill>
@@ -10241,7 +10241,7 @@
                 <a:cs typeface="Bai Jamjuree"/>
                 <a:ea typeface="Bai Jamjuree"/>
               </a:rPr>
-              <a:t>Material escaped from where it should be: spills, leaks, drips, weeps, vapour or gas releases (including a gas-detector alarm caused by a leak), steam or compressed air escaping, or liquid poured into the wrong drain. Vapour given off during normal handling (weighing or pouring on the bench) is not a release.</a:t>
+              <a:t>Material escaped from where it should be: spills, leaks, drips, weeps, vapour or gas releases (including a gas-detector alarm caused by a leak), steam or compressed air escaping, or liquid poured into the wrong drain. Vapour given off during normal handling (weighing or pouring on the bench) is not a release. Gas or vapour that burns as it comes out (a flame at a leak or at the neck of a flask) counts only as Fire, not also as a release.</a:t>
             </a:r>
           </a:p>
         </p:txBody>
@@ -10312,7 +10312,7 @@
         <p:spPr>
           <a:xfrm>
             <a:off x="7216444" y="2606040"/>
-            <a:ext cx="2015337" cy="2788920"/>
+            <a:ext cx="2015337" cy="3154680"/>
           </a:xfrm>
           <a:prstGeom prst="roundRect">
             <a:avLst>
@@ -10357,8 +10357,8 @@
         </p:nvSpPr>
         <p:spPr>
           <a:xfrm>
-            <a:off x="7289596" y="2670048"/>
-            <a:ext cx="1869033" cy="2651760"/>
+            <a:off x="7271308" y="2651760"/>
+            <a:ext cx="1905609" cy="3108960"/>
           </a:xfrm>
           <a:prstGeom prst="rect">
             <a:avLst/>
@@ -10371,7 +10371,7 @@
           <a:p>
             <a:pPr algn="l"/>
             <a:r>
-              <a:rPr sz="1400" b="0">
+              <a:rPr sz="1050" b="0">
                 <a:solidFill>
                   <a:srgbClr val="262626"/>
                 </a:solidFill>
@@ -10450,7 +10450,7 @@
         <p:spPr>
           <a:xfrm>
             <a:off x="9341510" y="2606040"/>
-            <a:ext cx="2015337" cy="2788920"/>
+            <a:ext cx="2015337" cy="3154680"/>
           </a:xfrm>
           <a:prstGeom prst="roundRect">
             <a:avLst>
@@ -10495,8 +10495,8 @@
         </p:nvSpPr>
         <p:spPr>
           <a:xfrm>
-            <a:off x="9414662" y="2670048"/>
-            <a:ext cx="1869033" cy="2651760"/>
+            <a:off x="9396374" y="2651760"/>
+            <a:ext cx="1905609" cy="3108960"/>
           </a:xfrm>
           <a:prstGeom prst="rect">
             <a:avLst/>
@@ -10509,7 +10509,7 @@
           <a:p>
             <a:pPr algn="l"/>
             <a:r>
-              <a:rPr sz="1400" b="0">
+              <a:rPr sz="1050" b="0">
                 <a:solidFill>
                   <a:srgbClr val="262626"/>
                 </a:solidFill>
@@ -10530,8 +10530,8 @@
         </p:nvSpPr>
         <p:spPr>
           <a:xfrm>
-            <a:off x="841248" y="5532120"/>
-            <a:ext cx="10515600" cy="548640"/>
+            <a:off x="841248" y="5852160"/>
+            <a:ext cx="10515600" cy="457200"/>
           </a:xfrm>
           <a:prstGeom prst="roundRect">
             <a:avLst>
@@ -10576,8 +10576,8 @@
         </p:nvSpPr>
         <p:spPr>
           <a:xfrm>
-            <a:off x="841248" y="5532120"/>
-            <a:ext cx="10515600" cy="548640"/>
+            <a:off x="841248" y="5852160"/>
+            <a:ext cx="10515600" cy="457200"/>
           </a:xfrm>
           <a:prstGeom prst="rect">
             <a:avLst/>
@@ -10676,7 +10676,7 @@
                 <a:cs typeface="Bai Jamjuree"/>
                 <a:ea typeface="Bai Jamjuree"/>
               </a:rPr>
-              <a:t>Check every part of the report and give the highest severity that any part meets</a:t>
+              <a:t>Check every part of the report and give the highest severity that any part meets, including parts that belong to a lower-priority type.</a:t>
             </a:r>
           </a:p>
         </p:txBody>
@@ -10715,8 +10715,8 @@
         </p:nvSpPr>
         <p:spPr>
           <a:xfrm>
-            <a:off x="841248" y="2057400"/>
-            <a:ext cx="3413759" cy="457200"/>
+            <a:off x="841248" y="2377440"/>
+            <a:ext cx="3413759" cy="411480"/>
           </a:xfrm>
           <a:prstGeom prst="roundRect">
             <a:avLst>
@@ -10751,7 +10751,7 @@
           <a:p>
             <a:pPr algn="ctr"/>
             <a:r>
-              <a:rPr sz="1700" b="1">
+              <a:rPr sz="1600" b="1">
                 <a:solidFill>
                   <a:srgbClr val="FFFFFF"/>
                 </a:solidFill>
@@ -10772,8 +10772,8 @@
         </p:nvSpPr>
         <p:spPr>
           <a:xfrm>
-            <a:off x="841248" y="2606040"/>
-            <a:ext cx="3413759" cy="3611880"/>
+            <a:off x="841248" y="2834640"/>
+            <a:ext cx="3413759" cy="3429000"/>
           </a:xfrm>
           <a:prstGeom prst="roundRect">
             <a:avLst>
@@ -10818,8 +10818,8 @@
         </p:nvSpPr>
         <p:spPr>
           <a:xfrm>
-            <a:off x="932688" y="2670048"/>
-            <a:ext cx="3230879" cy="3474720"/>
+            <a:off x="932688" y="2880360"/>
+            <a:ext cx="3230879" cy="3337560"/>
           </a:xfrm>
           <a:prstGeom prst="rect">
             <a:avLst/>
@@ -10832,7 +10832,7 @@
           <a:p>
             <a:pPr algn="l"/>
             <a:r>
-              <a:rPr sz="1350" b="0">
+              <a:rPr sz="1200" b="0">
                 <a:solidFill>
                   <a:srgbClr val="262626"/>
                 </a:solidFill>
@@ -10846,7 +10846,7 @@
           <a:p>
             <a:pPr algn="l"/>
             <a:r>
-              <a:rPr sz="1350" b="0">
+              <a:rPr sz="1200" b="0">
                 <a:solidFill>
                   <a:srgbClr val="262626"/>
                 </a:solidFill>
@@ -10860,7 +10860,7 @@
           <a:p>
             <a:pPr algn="l"/>
             <a:r>
-              <a:rPr sz="1350" b="0">
+              <a:rPr sz="1200" b="0">
                 <a:solidFill>
                   <a:srgbClr val="262626"/>
                 </a:solidFill>
@@ -10874,7 +10874,7 @@
           <a:p>
             <a:pPr algn="l"/>
             <a:r>
-              <a:rPr sz="1350" b="0">
+              <a:rPr sz="1200" b="0">
                 <a:solidFill>
                   <a:srgbClr val="262626"/>
                 </a:solidFill>
@@ -10888,7 +10888,7 @@
           <a:p>
             <a:pPr algn="l"/>
             <a:r>
-              <a:rPr sz="1350" b="0">
+              <a:rPr sz="1200" b="0">
                 <a:solidFill>
                   <a:srgbClr val="262626"/>
                 </a:solidFill>
@@ -10909,8 +10909,8 @@
         </p:nvSpPr>
         <p:spPr>
           <a:xfrm>
-            <a:off x="4392167" y="2057400"/>
-            <a:ext cx="3413759" cy="457200"/>
+            <a:off x="4392167" y="2377440"/>
+            <a:ext cx="3413759" cy="411480"/>
           </a:xfrm>
           <a:prstGeom prst="roundRect">
             <a:avLst>
@@ -10945,7 +10945,7 @@
           <a:p>
             <a:pPr algn="ctr"/>
             <a:r>
-              <a:rPr sz="1700" b="1">
+              <a:rPr sz="1600" b="1">
                 <a:solidFill>
                   <a:srgbClr val="FFFFFF"/>
                 </a:solidFill>
@@ -10966,8 +10966,8 @@
         </p:nvSpPr>
         <p:spPr>
           <a:xfrm>
-            <a:off x="4392167" y="2606040"/>
-            <a:ext cx="3413759" cy="3611880"/>
+            <a:off x="4392167" y="2834640"/>
+            <a:ext cx="3413759" cy="3429000"/>
           </a:xfrm>
           <a:prstGeom prst="roundRect">
             <a:avLst>
@@ -11012,8 +11012,8 @@
         </p:nvSpPr>
         <p:spPr>
           <a:xfrm>
-            <a:off x="4483607" y="2670048"/>
-            <a:ext cx="3230879" cy="3474720"/>
+            <a:off x="4483607" y="2880360"/>
+            <a:ext cx="3230879" cy="3337560"/>
           </a:xfrm>
           <a:prstGeom prst="rect">
             <a:avLst/>
@@ -11026,7 +11026,7 @@
           <a:p>
             <a:pPr algn="l"/>
             <a:r>
-              <a:rPr sz="1350" b="0">
+              <a:rPr sz="1200" b="0">
                 <a:solidFill>
                   <a:srgbClr val="262626"/>
                 </a:solidFill>
@@ -11040,7 +11040,7 @@
           <a:p>
             <a:pPr algn="l"/>
             <a:r>
-              <a:rPr sz="1350" b="0">
+              <a:rPr sz="1200" b="0">
                 <a:solidFill>
                   <a:srgbClr val="262626"/>
                 </a:solidFill>
@@ -11054,7 +11054,7 @@
           <a:p>
             <a:pPr algn="l"/>
             <a:r>
-              <a:rPr sz="1350" b="0">
+              <a:rPr sz="1200" b="0">
                 <a:solidFill>
                   <a:srgbClr val="262626"/>
                 </a:solidFill>
@@ -11068,7 +11068,7 @@
           <a:p>
             <a:pPr algn="l"/>
             <a:r>
-              <a:rPr sz="1350" b="0">
+              <a:rPr sz="1200" b="0">
                 <a:solidFill>
                   <a:srgbClr val="262626"/>
                 </a:solidFill>
@@ -11082,7 +11082,7 @@
           <a:p>
             <a:pPr algn="l"/>
             <a:r>
-              <a:rPr sz="1350" b="0">
+              <a:rPr sz="1200" b="0">
                 <a:solidFill>
                   <a:srgbClr val="262626"/>
                 </a:solidFill>
@@ -11103,8 +11103,8 @@
         </p:nvSpPr>
         <p:spPr>
           <a:xfrm>
-            <a:off x="7943087" y="2057400"/>
-            <a:ext cx="3413759" cy="457200"/>
+            <a:off x="7943087" y="2377440"/>
+            <a:ext cx="3413759" cy="411480"/>
           </a:xfrm>
           <a:prstGeom prst="roundRect">
             <a:avLst>
@@ -11139,7 +11139,7 @@
           <a:p>
             <a:pPr algn="ctr"/>
             <a:r>
-              <a:rPr sz="1700" b="1">
+              <a:rPr sz="1600" b="1">
                 <a:solidFill>
                   <a:srgbClr val="FFFFFF"/>
                 </a:solidFill>
@@ -11160,8 +11160,8 @@
         </p:nvSpPr>
         <p:spPr>
           <a:xfrm>
-            <a:off x="7943087" y="2606040"/>
-            <a:ext cx="3413759" cy="3611880"/>
+            <a:off x="7943087" y="2834640"/>
+            <a:ext cx="3413759" cy="3429000"/>
           </a:xfrm>
           <a:prstGeom prst="roundRect">
             <a:avLst>
@@ -11206,8 +11206,8 @@
         </p:nvSpPr>
         <p:spPr>
           <a:xfrm>
-            <a:off x="8034527" y="2670048"/>
-            <a:ext cx="3230879" cy="3474720"/>
+            <a:off x="8034527" y="2880360"/>
+            <a:ext cx="3230879" cy="3337560"/>
           </a:xfrm>
           <a:prstGeom prst="rect">
             <a:avLst/>
@@ -11220,7 +11220,7 @@
           <a:p>
             <a:pPr algn="l"/>
             <a:r>
-              <a:rPr sz="1350" b="0">
+              <a:rPr sz="1200" b="0">
                 <a:solidFill>
                   <a:srgbClr val="262626"/>
                 </a:solidFill>
@@ -11850,7 +11850,7 @@
                 <a:cs typeface="Bai Jamjuree"/>
                 <a:ea typeface="Bai Jamjuree"/>
               </a:rPr>
-              <a:t>Three worked examples</a:t>
+              <a:t>Four worked examples</a:t>
             </a:r>
           </a:p>
         </p:txBody>
@@ -11884,7 +11884,7 @@
                 <a:cs typeface="Bai Jamjuree"/>
                 <a:ea typeface="Bai Jamjuree"/>
               </a:rPr>
-              <a:t>These three are not among the 300 reports</a:t>
+              <a:t>These four are not among the 300 reports</a:t>
             </a:r>
           </a:p>
         </p:txBody>
@@ -11923,7 +11923,7 @@
         </p:nvSpPr>
         <p:spPr>
           <a:xfrm>
-            <a:off x="841248" y="2103120"/>
+            <a:off x="841248" y="2057400"/>
             <a:ext cx="4892040" cy="457200"/>
           </a:xfrm>
           <a:prstGeom prst="roundRect">
@@ -11980,8 +11980,8 @@
         </p:nvSpPr>
         <p:spPr>
           <a:xfrm>
-            <a:off x="5779008" y="2103120"/>
-            <a:ext cx="1417320" cy="457200"/>
+            <a:off x="5779008" y="2057400"/>
+            <a:ext cx="1234439" cy="457200"/>
           </a:xfrm>
           <a:prstGeom prst="roundRect">
             <a:avLst>
@@ -12037,8 +12037,8 @@
         </p:nvSpPr>
         <p:spPr>
           <a:xfrm>
-            <a:off x="7242048" y="2103120"/>
-            <a:ext cx="1417320" cy="457200"/>
+            <a:off x="7059168" y="2057400"/>
+            <a:ext cx="1234439" cy="457200"/>
           </a:xfrm>
           <a:prstGeom prst="roundRect">
             <a:avLst>
@@ -12094,8 +12094,8 @@
         </p:nvSpPr>
         <p:spPr>
           <a:xfrm>
-            <a:off x="8705088" y="2103120"/>
-            <a:ext cx="2606040" cy="457200"/>
+            <a:off x="8339328" y="2057400"/>
+            <a:ext cx="2971800" cy="457200"/>
           </a:xfrm>
           <a:prstGeom prst="roundRect">
             <a:avLst>
@@ -12151,8 +12151,8 @@
         </p:nvSpPr>
         <p:spPr>
           <a:xfrm>
-            <a:off x="841248" y="2615184"/>
-            <a:ext cx="4892040" cy="1042415"/>
+            <a:off x="841248" y="2569464"/>
+            <a:ext cx="4892040" cy="932688"/>
           </a:xfrm>
           <a:prstGeom prst="roundRect">
             <a:avLst>
@@ -12187,7 +12187,7 @@
           <a:p>
             <a:pPr algn="ctr"/>
             <a:r>
-              <a:rPr sz="1400" b="1">
+              <a:rPr sz="1300" b="1">
                 <a:solidFill>
                   <a:srgbClr val="262626"/>
                 </a:solidFill>
@@ -12208,8 +12208,8 @@
         </p:nvSpPr>
         <p:spPr>
           <a:xfrm>
-            <a:off x="5779008" y="2615184"/>
-            <a:ext cx="1417320" cy="1042415"/>
+            <a:off x="5779008" y="2569464"/>
+            <a:ext cx="1234439" cy="932688"/>
           </a:xfrm>
           <a:prstGeom prst="roundRect">
             <a:avLst>
@@ -12244,7 +12244,7 @@
           <a:p>
             <a:pPr algn="ctr"/>
             <a:r>
-              <a:rPr sz="1400" b="0">
+              <a:rPr sz="1300" b="0">
                 <a:solidFill>
                   <a:srgbClr val="262626"/>
                 </a:solidFill>
@@ -12265,8 +12265,8 @@
         </p:nvSpPr>
         <p:spPr>
           <a:xfrm>
-            <a:off x="7242048" y="2615184"/>
-            <a:ext cx="1417320" cy="1042415"/>
+            <a:off x="7059168" y="2569464"/>
+            <a:ext cx="1234439" cy="932688"/>
           </a:xfrm>
           <a:prstGeom prst="roundRect">
             <a:avLst>
@@ -12301,7 +12301,7 @@
           <a:p>
             <a:pPr algn="ctr"/>
             <a:r>
-              <a:rPr sz="1400" b="0">
+              <a:rPr sz="1300" b="0">
                 <a:solidFill>
                   <a:srgbClr val="262626"/>
                 </a:solidFill>
@@ -12322,8 +12322,8 @@
         </p:nvSpPr>
         <p:spPr>
           <a:xfrm>
-            <a:off x="8705088" y="2615184"/>
-            <a:ext cx="2606040" cy="1042415"/>
+            <a:off x="8339328" y="2569464"/>
+            <a:ext cx="2971800" cy="932688"/>
           </a:xfrm>
           <a:prstGeom prst="roundRect">
             <a:avLst>
@@ -12358,7 +12358,7 @@
           <a:p>
             <a:pPr algn="ctr"/>
             <a:r>
-              <a:rPr sz="1400" b="0">
+              <a:rPr sz="1300" b="0">
                 <a:solidFill>
                   <a:srgbClr val="262626"/>
                 </a:solidFill>
@@ -12379,8 +12379,8 @@
         </p:nvSpPr>
         <p:spPr>
           <a:xfrm>
-            <a:off x="841248" y="3712463"/>
-            <a:ext cx="4892040" cy="1042415"/>
+            <a:off x="841248" y="3557016"/>
+            <a:ext cx="4892040" cy="932688"/>
           </a:xfrm>
           <a:prstGeom prst="roundRect">
             <a:avLst>
@@ -12415,7 +12415,7 @@
           <a:p>
             <a:pPr algn="ctr"/>
             <a:r>
-              <a:rPr sz="1400" b="1">
+              <a:rPr sz="1300" b="1">
                 <a:solidFill>
                   <a:srgbClr val="262626"/>
                 </a:solidFill>
@@ -12436,8 +12436,8 @@
         </p:nvSpPr>
         <p:spPr>
           <a:xfrm>
-            <a:off x="5779008" y="3712463"/>
-            <a:ext cx="1417320" cy="1042415"/>
+            <a:off x="5779008" y="3557016"/>
+            <a:ext cx="1234439" cy="932688"/>
           </a:xfrm>
           <a:prstGeom prst="roundRect">
             <a:avLst>
@@ -12472,7 +12472,7 @@
           <a:p>
             <a:pPr algn="ctr"/>
             <a:r>
-              <a:rPr sz="1400" b="0">
+              <a:rPr sz="1300" b="0">
                 <a:solidFill>
                   <a:srgbClr val="262626"/>
                 </a:solidFill>
@@ -12493,8 +12493,8 @@
         </p:nvSpPr>
         <p:spPr>
           <a:xfrm>
-            <a:off x="7242048" y="3712463"/>
-            <a:ext cx="1417320" cy="1042415"/>
+            <a:off x="7059168" y="3557016"/>
+            <a:ext cx="1234439" cy="932688"/>
           </a:xfrm>
           <a:prstGeom prst="roundRect">
             <a:avLst>
@@ -12529,7 +12529,7 @@
           <a:p>
             <a:pPr algn="ctr"/>
             <a:r>
-              <a:rPr sz="1400" b="0">
+              <a:rPr sz="1300" b="0">
                 <a:solidFill>
                   <a:srgbClr val="262626"/>
                 </a:solidFill>
@@ -12550,8 +12550,8 @@
         </p:nvSpPr>
         <p:spPr>
           <a:xfrm>
-            <a:off x="8705088" y="3712463"/>
-            <a:ext cx="2606040" cy="1042415"/>
+            <a:off x="8339328" y="3557016"/>
+            <a:ext cx="2971800" cy="932688"/>
           </a:xfrm>
           <a:prstGeom prst="roundRect">
             <a:avLst>
@@ -12586,7 +12586,7 @@
           <a:p>
             <a:pPr algn="ctr"/>
             <a:r>
-              <a:rPr sz="1400" b="0">
+              <a:rPr sz="1300" b="0">
                 <a:solidFill>
                   <a:srgbClr val="262626"/>
                 </a:solidFill>
@@ -12607,8 +12607,8 @@
         </p:nvSpPr>
         <p:spPr>
           <a:xfrm>
-            <a:off x="841248" y="4809744"/>
-            <a:ext cx="4892040" cy="1042415"/>
+            <a:off x="841248" y="4544568"/>
+            <a:ext cx="4892040" cy="932688"/>
           </a:xfrm>
           <a:prstGeom prst="roundRect">
             <a:avLst>
@@ -12643,7 +12643,7 @@
           <a:p>
             <a:pPr algn="ctr"/>
             <a:r>
-              <a:rPr sz="1400" b="1">
+              <a:rPr sz="1300" b="1">
                 <a:solidFill>
                   <a:srgbClr val="262626"/>
                 </a:solidFill>
@@ -12664,8 +12664,8 @@
         </p:nvSpPr>
         <p:spPr>
           <a:xfrm>
-            <a:off x="5779008" y="4809744"/>
-            <a:ext cx="1417320" cy="1042415"/>
+            <a:off x="5779008" y="4544568"/>
+            <a:ext cx="1234439" cy="932688"/>
           </a:xfrm>
           <a:prstGeom prst="roundRect">
             <a:avLst>
@@ -12700,7 +12700,7 @@
           <a:p>
             <a:pPr algn="ctr"/>
             <a:r>
-              <a:rPr sz="1400" b="0">
+              <a:rPr sz="1300" b="0">
                 <a:solidFill>
                   <a:srgbClr val="262626"/>
                 </a:solidFill>
@@ -12721,8 +12721,8 @@
         </p:nvSpPr>
         <p:spPr>
           <a:xfrm>
-            <a:off x="7242048" y="4809744"/>
-            <a:ext cx="1417320" cy="1042415"/>
+            <a:off x="7059168" y="4544568"/>
+            <a:ext cx="1234439" cy="932688"/>
           </a:xfrm>
           <a:prstGeom prst="roundRect">
             <a:avLst>
@@ -12757,7 +12757,7 @@
           <a:p>
             <a:pPr algn="ctr"/>
             <a:r>
-              <a:rPr sz="1400" b="0">
+              <a:rPr sz="1300" b="0">
                 <a:solidFill>
                   <a:srgbClr val="262626"/>
                 </a:solidFill>
@@ -12778,8 +12778,8 @@
         </p:nvSpPr>
         <p:spPr>
           <a:xfrm>
-            <a:off x="8705088" y="4809744"/>
-            <a:ext cx="2606040" cy="1042415"/>
+            <a:off x="8339328" y="4544568"/>
+            <a:ext cx="2971800" cy="932688"/>
           </a:xfrm>
           <a:prstGeom prst="roundRect">
             <a:avLst>
@@ -12814,7 +12814,7 @@
           <a:p>
             <a:pPr algn="ctr"/>
             <a:r>
-              <a:rPr sz="1400" b="0">
+              <a:rPr sz="1300" b="0">
                 <a:solidFill>
                   <a:srgbClr val="262626"/>
                 </a:solidFill>
@@ -12823,6 +12823,234 @@
                 <a:ea typeface="Bai Jamjuree"/>
               </a:rPr>
               <a:t>Damage with no effect on work</a:t>
+            </a:r>
+          </a:p>
+        </p:txBody>
+      </p:sp>
+      <p:sp>
+        <p:nvSpPr>
+          <p:cNvPr id="21" name="Rounded Rectangle 20"/>
+          <p:cNvSpPr/>
+          <p:nvPr/>
+        </p:nvSpPr>
+        <p:spPr>
+          <a:xfrm>
+            <a:off x="841248" y="5532120"/>
+            <a:ext cx="4892040" cy="932688"/>
+          </a:xfrm>
+          <a:prstGeom prst="roundRect">
+            <a:avLst>
+              <a:gd name="adj" fmla="val 12000"/>
+            </a:avLst>
+          </a:prstGeom>
+          <a:solidFill>
+            <a:srgbClr val="EDEDED"/>
+          </a:solidFill>
+          <a:ln>
+            <a:noFill/>
+          </a:ln>
+          <a:effectLst/>
+        </p:spPr>
+        <p:style>
+          <a:lnRef idx="1">
+            <a:schemeClr val="accent1"/>
+          </a:lnRef>
+          <a:fillRef idx="3">
+            <a:schemeClr val="accent1"/>
+          </a:fillRef>
+          <a:effectRef idx="2">
+            <a:schemeClr val="accent1"/>
+          </a:effectRef>
+          <a:fontRef idx="minor">
+            <a:schemeClr val="lt1"/>
+          </a:fontRef>
+        </p:style>
+        <p:txBody>
+          <a:bodyPr rtlCol="0" anchor="ctr" wrap="square" lIns="36576" rIns="36576" tIns="36576" bIns="36576"/>
+          <a:lstStyle/>
+          <a:p>
+            <a:pPr algn="ctr"/>
+            <a:r>
+              <a:rPr sz="1300" b="1">
+                <a:solidFill>
+                  <a:srgbClr val="262626"/>
+                </a:solidFill>
+                <a:latin typeface="Bai Jamjuree"/>
+                <a:cs typeface="Bai Jamjuree"/>
+                <a:ea typeface="Bai Jamjuree"/>
+              </a:rPr>
+              <a:t>Student slipped carrying a 2 L bottle of methanol; it broke on the floor; bruised knee, cold pack.</a:t>
+            </a:r>
+          </a:p>
+        </p:txBody>
+      </p:sp>
+      <p:sp>
+        <p:nvSpPr>
+          <p:cNvPr id="22" name="Rounded Rectangle 21"/>
+          <p:cNvSpPr/>
+          <p:nvPr/>
+        </p:nvSpPr>
+        <p:spPr>
+          <a:xfrm>
+            <a:off x="5779008" y="5532120"/>
+            <a:ext cx="1234439" cy="932688"/>
+          </a:xfrm>
+          <a:prstGeom prst="roundRect">
+            <a:avLst>
+              <a:gd name="adj" fmla="val 12000"/>
+            </a:avLst>
+          </a:prstGeom>
+          <a:solidFill>
+            <a:srgbClr val="EDEDED"/>
+          </a:solidFill>
+          <a:ln>
+            <a:noFill/>
+          </a:ln>
+          <a:effectLst/>
+        </p:spPr>
+        <p:style>
+          <a:lnRef idx="1">
+            <a:schemeClr val="accent1"/>
+          </a:lnRef>
+          <a:fillRef idx="3">
+            <a:schemeClr val="accent1"/>
+          </a:fillRef>
+          <a:effectRef idx="2">
+            <a:schemeClr val="accent1"/>
+          </a:effectRef>
+          <a:fontRef idx="minor">
+            <a:schemeClr val="lt1"/>
+          </a:fontRef>
+        </p:style>
+        <p:txBody>
+          <a:bodyPr rtlCol="0" anchor="ctr" wrap="square" lIns="36576" rIns="36576" tIns="36576" bIns="36576"/>
+          <a:lstStyle/>
+          <a:p>
+            <a:pPr algn="ctr"/>
+            <a:r>
+              <a:rPr sz="1300" b="0">
+                <a:solidFill>
+                  <a:srgbClr val="262626"/>
+                </a:solidFill>
+                <a:latin typeface="Bai Jamjuree"/>
+                <a:cs typeface="Bai Jamjuree"/>
+                <a:ea typeface="Bai Jamjuree"/>
+              </a:rPr>
+              <a:t>Injury</a:t>
+            </a:r>
+          </a:p>
+        </p:txBody>
+      </p:sp>
+      <p:sp>
+        <p:nvSpPr>
+          <p:cNvPr id="23" name="Rounded Rectangle 22"/>
+          <p:cNvSpPr/>
+          <p:nvPr/>
+        </p:nvSpPr>
+        <p:spPr>
+          <a:xfrm>
+            <a:off x="7059168" y="5532120"/>
+            <a:ext cx="1234439" cy="932688"/>
+          </a:xfrm>
+          <a:prstGeom prst="roundRect">
+            <a:avLst>
+              <a:gd name="adj" fmla="val 12000"/>
+            </a:avLst>
+          </a:prstGeom>
+          <a:solidFill>
+            <a:srgbClr val="EDEDED"/>
+          </a:solidFill>
+          <a:ln>
+            <a:noFill/>
+          </a:ln>
+          <a:effectLst/>
+        </p:spPr>
+        <p:style>
+          <a:lnRef idx="1">
+            <a:schemeClr val="accent1"/>
+          </a:lnRef>
+          <a:fillRef idx="3">
+            <a:schemeClr val="accent1"/>
+          </a:fillRef>
+          <a:effectRef idx="2">
+            <a:schemeClr val="accent1"/>
+          </a:effectRef>
+          <a:fontRef idx="minor">
+            <a:schemeClr val="lt1"/>
+          </a:fontRef>
+        </p:style>
+        <p:txBody>
+          <a:bodyPr rtlCol="0" anchor="ctr" wrap="square" lIns="36576" rIns="36576" tIns="36576" bIns="36576"/>
+          <a:lstStyle/>
+          <a:p>
+            <a:pPr algn="ctr"/>
+            <a:r>
+              <a:rPr sz="1300" b="0">
+                <a:solidFill>
+                  <a:srgbClr val="262626"/>
+                </a:solidFill>
+                <a:latin typeface="Bai Jamjuree"/>
+                <a:cs typeface="Bai Jamjuree"/>
+                <a:ea typeface="Bai Jamjuree"/>
+              </a:rPr>
+              <a:t>High</a:t>
+            </a:r>
+          </a:p>
+        </p:txBody>
+      </p:sp>
+      <p:sp>
+        <p:nvSpPr>
+          <p:cNvPr id="24" name="Rounded Rectangle 23"/>
+          <p:cNvSpPr/>
+          <p:nvPr/>
+        </p:nvSpPr>
+        <p:spPr>
+          <a:xfrm>
+            <a:off x="8339328" y="5532120"/>
+            <a:ext cx="2971800" cy="932688"/>
+          </a:xfrm>
+          <a:prstGeom prst="roundRect">
+            <a:avLst>
+              <a:gd name="adj" fmla="val 12000"/>
+            </a:avLst>
+          </a:prstGeom>
+          <a:solidFill>
+            <a:srgbClr val="EDEDED"/>
+          </a:solidFill>
+          <a:ln>
+            <a:noFill/>
+          </a:ln>
+          <a:effectLst/>
+        </p:spPr>
+        <p:style>
+          <a:lnRef idx="1">
+            <a:schemeClr val="accent1"/>
+          </a:lnRef>
+          <a:fillRef idx="3">
+            <a:schemeClr val="accent1"/>
+          </a:fillRef>
+          <a:effectRef idx="2">
+            <a:schemeClr val="accent1"/>
+          </a:effectRef>
+          <a:fontRef idx="minor">
+            <a:schemeClr val="lt1"/>
+          </a:fontRef>
+        </p:style>
+        <p:txBody>
+          <a:bodyPr rtlCol="0" anchor="ctr" wrap="square" lIns="36576" rIns="36576" tIns="36576" bIns="36576"/>
+          <a:lstStyle/>
+          <a:p>
+            <a:pPr algn="ctr"/>
+            <a:r>
+              <a:rPr sz="1300" b="0">
+                <a:solidFill>
+                  <a:srgbClr val="262626"/>
+                </a:solidFill>
+                <a:latin typeface="Bai Jamjuree"/>
+                <a:cs typeface="Bai Jamjuree"/>
+                <a:ea typeface="Bai Jamjuree"/>
+              </a:rPr>
+              <a:t>Injury first; the spill (&gt;1 L, on the floor) makes it High</a:t>
             </a:r>
           </a:p>
         </p:txBody>
@@ -13541,7 +13769,7 @@
                 <a:cs typeface="Bai Jamjuree"/>
                 <a:ea typeface="Bai Jamjuree"/>
               </a:rPr>
-              <a:t>Was a fire extinguisher, sprinkler or fire brigade used?</a:t>
+              <a:t>Extinguisher, sprinkler, fire brigade or evacuation?</a:t>
             </a:r>
           </a:p>
         </p:txBody>
@@ -13788,6 +14016,129 @@
                 <a:ea typeface="Bai Jamjuree"/>
               </a:rPr>
               <a:t>Did the failure stop the work?</a:t>
+            </a:r>
+          </a:p>
+        </p:txBody>
+      </p:sp>
+      <p:sp>
+        <p:nvSpPr>
+          <p:cNvPr id="26" name="Rounded Rectangle 25"/>
+          <p:cNvSpPr/>
+          <p:nvPr/>
+        </p:nvSpPr>
+        <p:spPr>
+          <a:xfrm>
+            <a:off x="6190488" y="5212079"/>
+            <a:ext cx="5166360" cy="868680"/>
+          </a:xfrm>
+          <a:prstGeom prst="roundRect">
+            <a:avLst>
+              <a:gd name="adj" fmla="val 8000"/>
+            </a:avLst>
+          </a:prstGeom>
+          <a:solidFill>
+            <a:srgbClr val="FFFFFF"/>
+          </a:solidFill>
+          <a:ln w="15875">
+            <a:solidFill>
+              <a:srgbClr val="4472C4"/>
+            </a:solidFill>
+          </a:ln>
+          <a:effectLst/>
+        </p:spPr>
+        <p:style>
+          <a:lnRef idx="1">
+            <a:schemeClr val="accent1"/>
+          </a:lnRef>
+          <a:fillRef idx="3">
+            <a:schemeClr val="accent1"/>
+          </a:fillRef>
+          <a:effectRef idx="2">
+            <a:schemeClr val="accent1"/>
+          </a:effectRef>
+          <a:fontRef idx="minor">
+            <a:schemeClr val="lt1"/>
+          </a:fontRef>
+        </p:style>
+        <p:txBody>
+          <a:bodyPr rtlCol="0" anchor="ctr"/>
+          <a:lstStyle/>
+          <a:p/>
+        </p:txBody>
+      </p:sp>
+      <p:sp>
+        <p:nvSpPr>
+          <p:cNvPr id="27" name="Rectangle 26"/>
+          <p:cNvSpPr/>
+          <p:nvPr/>
+        </p:nvSpPr>
+        <p:spPr>
+          <a:xfrm>
+            <a:off x="6190488" y="5212079"/>
+            <a:ext cx="82296" cy="868680"/>
+          </a:xfrm>
+          <a:prstGeom prst="rect">
+            <a:avLst/>
+          </a:prstGeom>
+          <a:solidFill>
+            <a:srgbClr val="4472C4"/>
+          </a:solidFill>
+          <a:ln>
+            <a:noFill/>
+          </a:ln>
+          <a:effectLst/>
+        </p:spPr>
+        <p:style>
+          <a:lnRef idx="1">
+            <a:schemeClr val="accent1"/>
+          </a:lnRef>
+          <a:fillRef idx="3">
+            <a:schemeClr val="accent1"/>
+          </a:fillRef>
+          <a:effectRef idx="2">
+            <a:schemeClr val="accent1"/>
+          </a:effectRef>
+          <a:fontRef idx="minor">
+            <a:schemeClr val="lt1"/>
+          </a:fontRef>
+        </p:style>
+        <p:txBody>
+          <a:bodyPr rtlCol="0" anchor="ctr"/>
+          <a:lstStyle/>
+          <a:p/>
+        </p:txBody>
+      </p:sp>
+      <p:sp>
+        <p:nvSpPr>
+          <p:cNvPr id="28" name="TextBox 27"/>
+          <p:cNvSpPr txBox="1"/>
+          <p:nvPr/>
+        </p:nvSpPr>
+        <p:spPr>
+          <a:xfrm>
+            <a:off x="6336791" y="5266943"/>
+            <a:ext cx="4946904" cy="777240"/>
+          </a:xfrm>
+          <a:prstGeom prst="rect">
+            <a:avLst/>
+          </a:prstGeom>
+          <a:noFill/>
+        </p:spPr>
+        <p:txBody>
+          <a:bodyPr wrap="square" lIns="54864" rIns="54864" tIns="54864" bIns="54864" anchor="t"/>
+          <a:lstStyle/>
+          <a:p>
+            <a:pPr algn="l"/>
+            <a:r>
+              <a:rPr sz="1600" b="1">
+                <a:solidFill>
+                  <a:srgbClr val="262626"/>
+                </a:solidFill>
+                <a:latin typeface="Bai Jamjuree"/>
+                <a:cs typeface="Bai Jamjuree"/>
+                <a:ea typeface="Bai Jamjuree"/>
+              </a:rPr>
+              <a:t>Chemical in the eye, or treated beyond first aid?</a:t>
             </a:r>
           </a:p>
         </p:txBody>
@@ -14347,7 +14698,7 @@
                 <a:cs typeface="Bai Jamjuree"/>
                 <a:ea typeface="Bai Jamjuree"/>
               </a:rPr>
-              <a:t>Near miss</a:t>
+              <a:t>Equipment</a:t>
             </a:r>
           </a:p>
         </p:txBody>
@@ -14404,7 +14755,7 @@
                 <a:cs typeface="Bai Jamjuree"/>
                 <a:ea typeface="Bai Jamjuree"/>
               </a:rPr>
-              <a:t>Low</a:t>
+              <a:t>High</a:t>
             </a:r>
           </a:p>
         </p:txBody>
@@ -14860,7 +15211,7 @@
                 <a:cs typeface="Bai Jamjuree"/>
                 <a:ea typeface="Bai Jamjuree"/>
               </a:rPr>
-              <a:t>Equipment</a:t>
+              <a:t>Fire</a:t>
             </a:r>
           </a:p>
         </p:txBody>
@@ -14917,7 +15268,7 @@
                 <a:cs typeface="Bai Jamjuree"/>
                 <a:ea typeface="Bai Jamjuree"/>
               </a:rPr>
-              <a:t>Medium</a:t>
+              <a:t>High</a:t>
             </a:r>
           </a:p>
         </p:txBody>

</xml_diff>